<commit_message>
Final review, demo recorded
</commit_message>
<xml_diff>
--- a/Documents/Presentation/Presentation_PriyanshNayak.pptx
+++ b/Documents/Presentation/Presentation_PriyanshNayak.pptx
@@ -21740,7 +21740,7 @@
         <p:spPr>
           <a:xfrm>
             <a:off x="1524000" y="4159404"/>
-            <a:ext cx="9144000" cy="1098395"/>
+            <a:ext cx="9144000" cy="1500732"/>
           </a:xfrm>
         </p:spPr>
         <p:txBody>
@@ -21777,6 +21777,21 @@
               </a:rPr>
               <a:t>MSc Computer Science - Augmented and Virtual Reality</a:t>
             </a:r>
+          </a:p>
+          <a:p>
+            <a:r>
+              <a:rPr lang="en-IN" sz="1700" dirty="0">
+                <a:solidFill>
+                  <a:srgbClr val="FFFFFF"/>
+                </a:solidFill>
+              </a:rPr>
+              <a:t>Trinity College Dublin</a:t>
+            </a:r>
+            <a:endParaRPr lang="en-IN" sz="1700" noProof="0" dirty="0">
+              <a:solidFill>
+                <a:srgbClr val="FFFFFF"/>
+              </a:solidFill>
+            </a:endParaRPr>
           </a:p>
         </p:txBody>
       </p:sp>

</xml_diff>